<commit_message>
Added powerpoint (for real this time)
</commit_message>
<xml_diff>
--- a/The art and science of developing interesting solutions.pptx
+++ b/The art and science of developing interesting solutions.pptx
@@ -4,15 +4,19 @@
   <p:sldMasterIdLst>
     <p:sldMasterId id="2147483648" r:id="rId1"/>
   </p:sldMasterIdLst>
+  <p:notesMasterIdLst>
+    <p:notesMasterId r:id="rId11"/>
+  </p:notesMasterIdLst>
   <p:sldIdLst>
     <p:sldId id="256" r:id="rId2"/>
     <p:sldId id="261" r:id="rId3"/>
     <p:sldId id="262" r:id="rId4"/>
     <p:sldId id="266" r:id="rId5"/>
-    <p:sldId id="263" r:id="rId6"/>
-    <p:sldId id="264" r:id="rId7"/>
-    <p:sldId id="265" r:id="rId8"/>
-    <p:sldId id="267" r:id="rId9"/>
+    <p:sldId id="268" r:id="rId6"/>
+    <p:sldId id="265" r:id="rId7"/>
+    <p:sldId id="264" r:id="rId8"/>
+    <p:sldId id="263" r:id="rId9"/>
+    <p:sldId id="267" r:id="rId10"/>
   </p:sldIdLst>
   <p:sldSz cx="12192000" cy="6858000"/>
   <p:notesSz cx="6858000" cy="9144000"/>
@@ -132,7 +136,7 @@
   <pc:docChgLst>
     <pc:chgData name="imnot tellingyouthat" userId="eb6948bf3582b151" providerId="LiveId" clId="{0790150D-C5A1-4F69-B22D-9782578A233B}"/>
     <pc:docChg chg="undo custSel addSld delSld modSld sldOrd">
-      <pc:chgData name="imnot tellingyouthat" userId="eb6948bf3582b151" providerId="LiveId" clId="{0790150D-C5A1-4F69-B22D-9782578A233B}" dt="2026-10-10T01:20:13.777" v="1462" actId="20577"/>
+      <pc:chgData name="imnot tellingyouthat" userId="eb6948bf3582b151" providerId="LiveId" clId="{0790150D-C5A1-4F69-B22D-9782578A233B}" dt="2026-10-10T01:34:53.323" v="3188" actId="20577"/>
       <pc:docMkLst>
         <pc:docMk/>
       </pc:docMkLst>
@@ -362,8 +366,8 @@
           </ac:graphicFrameMkLst>
         </pc:graphicFrameChg>
       </pc:sldChg>
-      <pc:sldChg chg="addSp delSp modSp new mod modTransition setBg addAnim delAnim modAnim">
-        <pc:chgData name="imnot tellingyouthat" userId="eb6948bf3582b151" providerId="LiveId" clId="{0790150D-C5A1-4F69-B22D-9782578A233B}" dt="2026-10-10T01:09:38.298" v="1200"/>
+      <pc:sldChg chg="addSp delSp modSp new mod modTransition setBg addAnim delAnim modAnim modNotesTx">
+        <pc:chgData name="imnot tellingyouthat" userId="eb6948bf3582b151" providerId="LiveId" clId="{0790150D-C5A1-4F69-B22D-9782578A233B}" dt="2026-10-10T01:27:53.336" v="2167" actId="20577"/>
         <pc:sldMkLst>
           <pc:docMk/>
           <pc:sldMk cId="169284293" sldId="262"/>
@@ -481,23 +485,55 @@
           </ac:cxnSpMkLst>
         </pc:cxnChg>
       </pc:sldChg>
-      <pc:sldChg chg="modSp new mod">
-        <pc:chgData name="imnot tellingyouthat" userId="eb6948bf3582b151" providerId="LiveId" clId="{0790150D-C5A1-4F69-B22D-9782578A233B}" dt="2026-10-10T00:22:42.250" v="748" actId="20577"/>
+      <pc:sldChg chg="addSp modSp new mod setBg">
+        <pc:chgData name="imnot tellingyouthat" userId="eb6948bf3582b151" providerId="LiveId" clId="{0790150D-C5A1-4F69-B22D-9782578A233B}" dt="2026-10-10T01:32:05.589" v="2662" actId="26606"/>
         <pc:sldMkLst>
           <pc:docMk/>
           <pc:sldMk cId="2457606381" sldId="263"/>
         </pc:sldMkLst>
         <pc:spChg chg="mod">
-          <ac:chgData name="imnot tellingyouthat" userId="eb6948bf3582b151" providerId="LiveId" clId="{0790150D-C5A1-4F69-B22D-9782578A233B}" dt="2026-10-10T00:22:42.250" v="748" actId="20577"/>
+          <ac:chgData name="imnot tellingyouthat" userId="eb6948bf3582b151" providerId="LiveId" clId="{0790150D-C5A1-4F69-B22D-9782578A233B}" dt="2026-10-10T01:32:05.589" v="2662" actId="26606"/>
           <ac:spMkLst>
             <pc:docMk/>
             <pc:sldMk cId="2457606381" sldId="263"/>
             <ac:spMk id="2" creationId="{21A33ED2-2FE0-2D84-4567-165D2858CBC6}"/>
           </ac:spMkLst>
         </pc:spChg>
+        <pc:spChg chg="mod">
+          <ac:chgData name="imnot tellingyouthat" userId="eb6948bf3582b151" providerId="LiveId" clId="{0790150D-C5A1-4F69-B22D-9782578A233B}" dt="2026-10-10T01:32:05.589" v="2662" actId="26606"/>
+          <ac:spMkLst>
+            <pc:docMk/>
+            <pc:sldMk cId="2457606381" sldId="263"/>
+            <ac:spMk id="3" creationId="{CD8C4A33-ACE3-89C1-4AE6-ADFBA53AB21F}"/>
+          </ac:spMkLst>
+        </pc:spChg>
+        <pc:spChg chg="add">
+          <ac:chgData name="imnot tellingyouthat" userId="eb6948bf3582b151" providerId="LiveId" clId="{0790150D-C5A1-4F69-B22D-9782578A233B}" dt="2026-10-10T01:32:05.589" v="2662" actId="26606"/>
+          <ac:spMkLst>
+            <pc:docMk/>
+            <pc:sldMk cId="2457606381" sldId="263"/>
+            <ac:spMk id="9" creationId="{F13C74B1-5B17-4795-BED0-7140497B445A}"/>
+          </ac:spMkLst>
+        </pc:spChg>
+        <pc:spChg chg="add">
+          <ac:chgData name="imnot tellingyouthat" userId="eb6948bf3582b151" providerId="LiveId" clId="{0790150D-C5A1-4F69-B22D-9782578A233B}" dt="2026-10-10T01:32:05.589" v="2662" actId="26606"/>
+          <ac:spMkLst>
+            <pc:docMk/>
+            <pc:sldMk cId="2457606381" sldId="263"/>
+            <ac:spMk id="11" creationId="{D4974D33-8DC5-464E-8C6D-BE58F0669C17}"/>
+          </ac:spMkLst>
+        </pc:spChg>
+        <pc:picChg chg="add mod">
+          <ac:chgData name="imnot tellingyouthat" userId="eb6948bf3582b151" providerId="LiveId" clId="{0790150D-C5A1-4F69-B22D-9782578A233B}" dt="2026-10-10T01:32:05.589" v="2662" actId="26606"/>
+          <ac:picMkLst>
+            <pc:docMk/>
+            <pc:sldMk cId="2457606381" sldId="263"/>
+            <ac:picMk id="4" creationId="{5D5879D5-B143-DC32-EC32-DE5C3738782F}"/>
+          </ac:picMkLst>
+        </pc:picChg>
       </pc:sldChg>
-      <pc:sldChg chg="modSp new mod">
-        <pc:chgData name="imnot tellingyouthat" userId="eb6948bf3582b151" providerId="LiveId" clId="{0790150D-C5A1-4F69-B22D-9782578A233B}" dt="2026-10-10T00:23:26.927" v="848" actId="20577"/>
+      <pc:sldChg chg="modSp new mod ord">
+        <pc:chgData name="imnot tellingyouthat" userId="eb6948bf3582b151" providerId="LiveId" clId="{0790150D-C5A1-4F69-B22D-9782578A233B}" dt="2026-10-10T01:32:46.967" v="2761" actId="20577"/>
         <pc:sldMkLst>
           <pc:docMk/>
           <pc:sldMk cId="3872863384" sldId="264"/>
@@ -511,7 +547,7 @@
           </ac:spMkLst>
         </pc:spChg>
         <pc:spChg chg="mod">
-          <ac:chgData name="imnot tellingyouthat" userId="eb6948bf3582b151" providerId="LiveId" clId="{0790150D-C5A1-4F69-B22D-9782578A233B}" dt="2026-10-10T00:23:26.927" v="848" actId="20577"/>
+          <ac:chgData name="imnot tellingyouthat" userId="eb6948bf3582b151" providerId="LiveId" clId="{0790150D-C5A1-4F69-B22D-9782578A233B}" dt="2026-10-10T01:32:46.967" v="2761" actId="20577"/>
           <ac:spMkLst>
             <pc:docMk/>
             <pc:sldMk cId="3872863384" sldId="264"/>
@@ -519,8 +555,8 @@
           </ac:spMkLst>
         </pc:spChg>
       </pc:sldChg>
-      <pc:sldChg chg="modSp new mod">
-        <pc:chgData name="imnot tellingyouthat" userId="eb6948bf3582b151" providerId="LiveId" clId="{0790150D-C5A1-4F69-B22D-9782578A233B}" dt="2026-10-10T01:10:37.389" v="1260" actId="20577"/>
+      <pc:sldChg chg="modSp new mod ord">
+        <pc:chgData name="imnot tellingyouthat" userId="eb6948bf3582b151" providerId="LiveId" clId="{0790150D-C5A1-4F69-B22D-9782578A233B}" dt="2026-10-10T01:30:00.899" v="2491"/>
         <pc:sldMkLst>
           <pc:docMk/>
           <pc:sldMk cId="2026042837" sldId="265"/>
@@ -531,6 +567,14 @@
             <pc:docMk/>
             <pc:sldMk cId="2026042837" sldId="265"/>
             <ac:spMk id="2" creationId="{9441E233-A118-C09D-2624-09955E55BF70}"/>
+          </ac:spMkLst>
+        </pc:spChg>
+        <pc:spChg chg="mod">
+          <ac:chgData name="imnot tellingyouthat" userId="eb6948bf3582b151" providerId="LiveId" clId="{0790150D-C5A1-4F69-B22D-9782578A233B}" dt="2026-10-10T01:29:36.908" v="2464" actId="20577"/>
+          <ac:spMkLst>
+            <pc:docMk/>
+            <pc:sldMk cId="2026042837" sldId="265"/>
+            <ac:spMk id="3" creationId="{C15BACF4-3F67-3001-DB61-8035FD2781A7}"/>
           </ac:spMkLst>
         </pc:spChg>
       </pc:sldChg>
@@ -636,9 +680,476 @@
           </ac:picMkLst>
         </pc:picChg>
       </pc:sldChg>
+      <pc:sldChg chg="modSp new mod ord">
+        <pc:chgData name="imnot tellingyouthat" userId="eb6948bf3582b151" providerId="LiveId" clId="{0790150D-C5A1-4F69-B22D-9782578A233B}" dt="2026-10-10T01:34:53.323" v="3188" actId="20577"/>
+        <pc:sldMkLst>
+          <pc:docMk/>
+          <pc:sldMk cId="1918873932" sldId="268"/>
+        </pc:sldMkLst>
+        <pc:spChg chg="mod">
+          <ac:chgData name="imnot tellingyouthat" userId="eb6948bf3582b151" providerId="LiveId" clId="{0790150D-C5A1-4F69-B22D-9782578A233B}" dt="2026-10-10T01:33:00.099" v="2772" actId="20577"/>
+          <ac:spMkLst>
+            <pc:docMk/>
+            <pc:sldMk cId="1918873932" sldId="268"/>
+            <ac:spMk id="2" creationId="{CA267BC9-37FA-2B21-86EC-08DAB1484C41}"/>
+          </ac:spMkLst>
+        </pc:spChg>
+        <pc:spChg chg="mod">
+          <ac:chgData name="imnot tellingyouthat" userId="eb6948bf3582b151" providerId="LiveId" clId="{0790150D-C5A1-4F69-B22D-9782578A233B}" dt="2026-10-10T01:34:53.323" v="3188" actId="20577"/>
+          <ac:spMkLst>
+            <pc:docMk/>
+            <pc:sldMk cId="1918873932" sldId="268"/>
+            <ac:spMk id="3" creationId="{226F537D-BA02-8B44-4322-B0F0C31877C5}"/>
+          </ac:spMkLst>
+        </pc:spChg>
+      </pc:sldChg>
     </pc:docChg>
   </pc:docChgLst>
 </pc:chgInfo>
+</file>
+
+<file path=ppt/notesMasters/notesMaster1.xml><?xml version="1.0" encoding="utf-8"?>
+<p:notesMaster xmlns:a="http://schemas.openxmlformats.org/drawingml/2006/main" xmlns:r="http://schemas.openxmlformats.org/officeDocument/2006/relationships" xmlns:p="http://schemas.openxmlformats.org/presentationml/2006/main">
+  <p:cSld>
+    <p:bg>
+      <p:bgRef idx="1001">
+        <a:schemeClr val="bg1"/>
+      </p:bgRef>
+    </p:bg>
+    <p:spTree>
+      <p:nvGrpSpPr>
+        <p:cNvPr id="1" name=""/>
+        <p:cNvGrpSpPr/>
+        <p:nvPr/>
+      </p:nvGrpSpPr>
+      <p:grpSpPr>
+        <a:xfrm>
+          <a:off x="0" y="0"/>
+          <a:ext cx="0" cy="0"/>
+          <a:chOff x="0" y="0"/>
+          <a:chExt cx="0" cy="0"/>
+        </a:xfrm>
+      </p:grpSpPr>
+      <p:sp>
+        <p:nvSpPr>
+          <p:cNvPr id="2" name="Header Placeholder 1"/>
+          <p:cNvSpPr>
+            <a:spLocks noGrp="1"/>
+          </p:cNvSpPr>
+          <p:nvPr>
+            <p:ph type="hdr" sz="quarter"/>
+          </p:nvPr>
+        </p:nvSpPr>
+        <p:spPr>
+          <a:xfrm>
+            <a:off x="0" y="0"/>
+            <a:ext cx="2971800" cy="458788"/>
+          </a:xfrm>
+          <a:prstGeom prst="rect">
+            <a:avLst/>
+          </a:prstGeom>
+        </p:spPr>
+        <p:txBody>
+          <a:bodyPr vert="horz" lIns="91440" tIns="45720" rIns="91440" bIns="45720" rtlCol="0"/>
+          <a:lstStyle>
+            <a:lvl1pPr algn="l">
+              <a:defRPr sz="1200"/>
+            </a:lvl1pPr>
+          </a:lstStyle>
+          <a:p>
+            <a:endParaRPr lang="en-US"/>
+          </a:p>
+        </p:txBody>
+      </p:sp>
+      <p:sp>
+        <p:nvSpPr>
+          <p:cNvPr id="3" name="Date Placeholder 2"/>
+          <p:cNvSpPr>
+            <a:spLocks noGrp="1"/>
+          </p:cNvSpPr>
+          <p:nvPr>
+            <p:ph type="dt" idx="1"/>
+          </p:nvPr>
+        </p:nvSpPr>
+        <p:spPr>
+          <a:xfrm>
+            <a:off x="3884613" y="0"/>
+            <a:ext cx="2971800" cy="458788"/>
+          </a:xfrm>
+          <a:prstGeom prst="rect">
+            <a:avLst/>
+          </a:prstGeom>
+        </p:spPr>
+        <p:txBody>
+          <a:bodyPr vert="horz" lIns="91440" tIns="45720" rIns="91440" bIns="45720" rtlCol="0"/>
+          <a:lstStyle>
+            <a:lvl1pPr algn="r">
+              <a:defRPr sz="1200"/>
+            </a:lvl1pPr>
+          </a:lstStyle>
+          <a:p>
+            <a:fld id="{8541AA0F-358E-4B4D-90A4-4A1B4F034CE9}" type="datetimeFigureOut">
+              <a:rPr lang="en-US" smtClean="0"/>
+              <a:t>10/9/2026</a:t>
+            </a:fld>
+            <a:endParaRPr lang="en-US"/>
+          </a:p>
+        </p:txBody>
+      </p:sp>
+      <p:sp>
+        <p:nvSpPr>
+          <p:cNvPr id="4" name="Slide Image Placeholder 3"/>
+          <p:cNvSpPr>
+            <a:spLocks noGrp="1" noRot="1" noChangeAspect="1"/>
+          </p:cNvSpPr>
+          <p:nvPr>
+            <p:ph type="sldImg" idx="2"/>
+          </p:nvPr>
+        </p:nvSpPr>
+        <p:spPr>
+          <a:xfrm>
+            <a:off x="685800" y="1143000"/>
+            <a:ext cx="5486400" cy="3086100"/>
+          </a:xfrm>
+          <a:prstGeom prst="rect">
+            <a:avLst/>
+          </a:prstGeom>
+          <a:noFill/>
+          <a:ln w="12700">
+            <a:solidFill>
+              <a:prstClr val="black"/>
+            </a:solidFill>
+          </a:ln>
+        </p:spPr>
+        <p:txBody>
+          <a:bodyPr vert="horz" lIns="91440" tIns="45720" rIns="91440" bIns="45720" rtlCol="0" anchor="ctr"/>
+          <a:lstStyle/>
+          <a:p>
+            <a:endParaRPr lang="en-US"/>
+          </a:p>
+        </p:txBody>
+      </p:sp>
+      <p:sp>
+        <p:nvSpPr>
+          <p:cNvPr id="5" name="Notes Placeholder 4"/>
+          <p:cNvSpPr>
+            <a:spLocks noGrp="1"/>
+          </p:cNvSpPr>
+          <p:nvPr>
+            <p:ph type="body" sz="quarter" idx="3"/>
+          </p:nvPr>
+        </p:nvSpPr>
+        <p:spPr>
+          <a:xfrm>
+            <a:off x="685800" y="4400550"/>
+            <a:ext cx="5486400" cy="3600450"/>
+          </a:xfrm>
+          <a:prstGeom prst="rect">
+            <a:avLst/>
+          </a:prstGeom>
+        </p:spPr>
+        <p:txBody>
+          <a:bodyPr vert="horz" lIns="91440" tIns="45720" rIns="91440" bIns="45720" rtlCol="0"/>
+          <a:lstStyle/>
+          <a:p>
+            <a:pPr lvl="0"/>
+            <a:r>
+              <a:rPr lang="en-US"/>
+              <a:t>Click to edit Master text styles</a:t>
+            </a:r>
+          </a:p>
+          <a:p>
+            <a:pPr lvl="1"/>
+            <a:r>
+              <a:rPr lang="en-US"/>
+              <a:t>Second level</a:t>
+            </a:r>
+          </a:p>
+          <a:p>
+            <a:pPr lvl="2"/>
+            <a:r>
+              <a:rPr lang="en-US"/>
+              <a:t>Third level</a:t>
+            </a:r>
+          </a:p>
+          <a:p>
+            <a:pPr lvl="3"/>
+            <a:r>
+              <a:rPr lang="en-US"/>
+              <a:t>Fourth level</a:t>
+            </a:r>
+          </a:p>
+          <a:p>
+            <a:pPr lvl="4"/>
+            <a:r>
+              <a:rPr lang="en-US"/>
+              <a:t>Fifth level</a:t>
+            </a:r>
+          </a:p>
+        </p:txBody>
+      </p:sp>
+      <p:sp>
+        <p:nvSpPr>
+          <p:cNvPr id="6" name="Footer Placeholder 5"/>
+          <p:cNvSpPr>
+            <a:spLocks noGrp="1"/>
+          </p:cNvSpPr>
+          <p:nvPr>
+            <p:ph type="ftr" sz="quarter" idx="4"/>
+          </p:nvPr>
+        </p:nvSpPr>
+        <p:spPr>
+          <a:xfrm>
+            <a:off x="0" y="8685213"/>
+            <a:ext cx="2971800" cy="458787"/>
+          </a:xfrm>
+          <a:prstGeom prst="rect">
+            <a:avLst/>
+          </a:prstGeom>
+        </p:spPr>
+        <p:txBody>
+          <a:bodyPr vert="horz" lIns="91440" tIns="45720" rIns="91440" bIns="45720" rtlCol="0" anchor="b"/>
+          <a:lstStyle>
+            <a:lvl1pPr algn="l">
+              <a:defRPr sz="1200"/>
+            </a:lvl1pPr>
+          </a:lstStyle>
+          <a:p>
+            <a:endParaRPr lang="en-US"/>
+          </a:p>
+        </p:txBody>
+      </p:sp>
+      <p:sp>
+        <p:nvSpPr>
+          <p:cNvPr id="7" name="Slide Number Placeholder 6"/>
+          <p:cNvSpPr>
+            <a:spLocks noGrp="1"/>
+          </p:cNvSpPr>
+          <p:nvPr>
+            <p:ph type="sldNum" sz="quarter" idx="5"/>
+          </p:nvPr>
+        </p:nvSpPr>
+        <p:spPr>
+          <a:xfrm>
+            <a:off x="3884613" y="8685213"/>
+            <a:ext cx="2971800" cy="458787"/>
+          </a:xfrm>
+          <a:prstGeom prst="rect">
+            <a:avLst/>
+          </a:prstGeom>
+        </p:spPr>
+        <p:txBody>
+          <a:bodyPr vert="horz" lIns="91440" tIns="45720" rIns="91440" bIns="45720" rtlCol="0" anchor="b"/>
+          <a:lstStyle>
+            <a:lvl1pPr algn="r">
+              <a:defRPr sz="1200"/>
+            </a:lvl1pPr>
+          </a:lstStyle>
+          <a:p>
+            <a:fld id="{FC9F8D2F-DF87-4E8D-892D-1D9C898E4280}" type="slidenum">
+              <a:rPr lang="en-US" smtClean="0"/>
+              <a:t>‹#›</a:t>
+            </a:fld>
+            <a:endParaRPr lang="en-US"/>
+          </a:p>
+        </p:txBody>
+      </p:sp>
+    </p:spTree>
+    <p:extLst>
+      <p:ext uri="{BB962C8B-B14F-4D97-AF65-F5344CB8AC3E}">
+        <p14:creationId xmlns:p14="http://schemas.microsoft.com/office/powerpoint/2010/main" val="1751526368"/>
+      </p:ext>
+    </p:extLst>
+  </p:cSld>
+  <p:clrMap bg1="lt1" tx1="dk1" bg2="lt2" tx2="dk2" accent1="accent1" accent2="accent2" accent3="accent3" accent4="accent4" accent5="accent5" accent6="accent6" hlink="hlink" folHlink="folHlink"/>
+  <p:notesStyle>
+    <a:lvl1pPr marL="0" algn="l" defTabSz="914400" rtl="0" eaLnBrk="1" latinLnBrk="0" hangingPunct="1">
+      <a:defRPr sz="1200" kern="1200">
+        <a:solidFill>
+          <a:schemeClr val="tx1"/>
+        </a:solidFill>
+        <a:latin typeface="+mn-lt"/>
+        <a:ea typeface="+mn-ea"/>
+        <a:cs typeface="+mn-cs"/>
+      </a:defRPr>
+    </a:lvl1pPr>
+    <a:lvl2pPr marL="457200" algn="l" defTabSz="914400" rtl="0" eaLnBrk="1" latinLnBrk="0" hangingPunct="1">
+      <a:defRPr sz="1200" kern="1200">
+        <a:solidFill>
+          <a:schemeClr val="tx1"/>
+        </a:solidFill>
+        <a:latin typeface="+mn-lt"/>
+        <a:ea typeface="+mn-ea"/>
+        <a:cs typeface="+mn-cs"/>
+      </a:defRPr>
+    </a:lvl2pPr>
+    <a:lvl3pPr marL="914400" algn="l" defTabSz="914400" rtl="0" eaLnBrk="1" latinLnBrk="0" hangingPunct="1">
+      <a:defRPr sz="1200" kern="1200">
+        <a:solidFill>
+          <a:schemeClr val="tx1"/>
+        </a:solidFill>
+        <a:latin typeface="+mn-lt"/>
+        <a:ea typeface="+mn-ea"/>
+        <a:cs typeface="+mn-cs"/>
+      </a:defRPr>
+    </a:lvl3pPr>
+    <a:lvl4pPr marL="1371600" algn="l" defTabSz="914400" rtl="0" eaLnBrk="1" latinLnBrk="0" hangingPunct="1">
+      <a:defRPr sz="1200" kern="1200">
+        <a:solidFill>
+          <a:schemeClr val="tx1"/>
+        </a:solidFill>
+        <a:latin typeface="+mn-lt"/>
+        <a:ea typeface="+mn-ea"/>
+        <a:cs typeface="+mn-cs"/>
+      </a:defRPr>
+    </a:lvl4pPr>
+    <a:lvl5pPr marL="1828800" algn="l" defTabSz="914400" rtl="0" eaLnBrk="1" latinLnBrk="0" hangingPunct="1">
+      <a:defRPr sz="1200" kern="1200">
+        <a:solidFill>
+          <a:schemeClr val="tx1"/>
+        </a:solidFill>
+        <a:latin typeface="+mn-lt"/>
+        <a:ea typeface="+mn-ea"/>
+        <a:cs typeface="+mn-cs"/>
+      </a:defRPr>
+    </a:lvl5pPr>
+    <a:lvl6pPr marL="2286000" algn="l" defTabSz="914400" rtl="0" eaLnBrk="1" latinLnBrk="0" hangingPunct="1">
+      <a:defRPr sz="1200" kern="1200">
+        <a:solidFill>
+          <a:schemeClr val="tx1"/>
+        </a:solidFill>
+        <a:latin typeface="+mn-lt"/>
+        <a:ea typeface="+mn-ea"/>
+        <a:cs typeface="+mn-cs"/>
+      </a:defRPr>
+    </a:lvl6pPr>
+    <a:lvl7pPr marL="2743200" algn="l" defTabSz="914400" rtl="0" eaLnBrk="1" latinLnBrk="0" hangingPunct="1">
+      <a:defRPr sz="1200" kern="1200">
+        <a:solidFill>
+          <a:schemeClr val="tx1"/>
+        </a:solidFill>
+        <a:latin typeface="+mn-lt"/>
+        <a:ea typeface="+mn-ea"/>
+        <a:cs typeface="+mn-cs"/>
+      </a:defRPr>
+    </a:lvl7pPr>
+    <a:lvl8pPr marL="3200400" algn="l" defTabSz="914400" rtl="0" eaLnBrk="1" latinLnBrk="0" hangingPunct="1">
+      <a:defRPr sz="1200" kern="1200">
+        <a:solidFill>
+          <a:schemeClr val="tx1"/>
+        </a:solidFill>
+        <a:latin typeface="+mn-lt"/>
+        <a:ea typeface="+mn-ea"/>
+        <a:cs typeface="+mn-cs"/>
+      </a:defRPr>
+    </a:lvl8pPr>
+    <a:lvl9pPr marL="3657600" algn="l" defTabSz="914400" rtl="0" eaLnBrk="1" latinLnBrk="0" hangingPunct="1">
+      <a:defRPr sz="1200" kern="1200">
+        <a:solidFill>
+          <a:schemeClr val="tx1"/>
+        </a:solidFill>
+        <a:latin typeface="+mn-lt"/>
+        <a:ea typeface="+mn-ea"/>
+        <a:cs typeface="+mn-cs"/>
+      </a:defRPr>
+    </a:lvl9pPr>
+  </p:notesStyle>
+</p:notesMaster>
+</file>
+
+<file path=ppt/notesSlides/notesSlide1.xml><?xml version="1.0" encoding="utf-8"?>
+<p:notes xmlns:a="http://schemas.openxmlformats.org/drawingml/2006/main" xmlns:r="http://schemas.openxmlformats.org/officeDocument/2006/relationships" xmlns:p="http://schemas.openxmlformats.org/presentationml/2006/main">
+  <p:cSld>
+    <p:spTree>
+      <p:nvGrpSpPr>
+        <p:cNvPr id="1" name=""/>
+        <p:cNvGrpSpPr/>
+        <p:nvPr/>
+      </p:nvGrpSpPr>
+      <p:grpSpPr>
+        <a:xfrm>
+          <a:off x="0" y="0"/>
+          <a:ext cx="0" cy="0"/>
+          <a:chOff x="0" y="0"/>
+          <a:chExt cx="0" cy="0"/>
+        </a:xfrm>
+      </p:grpSpPr>
+      <p:sp>
+        <p:nvSpPr>
+          <p:cNvPr id="2" name="Slide Image Placeholder 1"/>
+          <p:cNvSpPr>
+            <a:spLocks noGrp="1" noRot="1" noChangeAspect="1"/>
+          </p:cNvSpPr>
+          <p:nvPr>
+            <p:ph type="sldImg"/>
+          </p:nvPr>
+        </p:nvSpPr>
+        <p:spPr/>
+      </p:sp>
+      <p:sp>
+        <p:nvSpPr>
+          <p:cNvPr id="3" name="Notes Placeholder 2"/>
+          <p:cNvSpPr>
+            <a:spLocks noGrp="1"/>
+          </p:cNvSpPr>
+          <p:nvPr>
+            <p:ph type="body" idx="1"/>
+          </p:nvPr>
+        </p:nvSpPr>
+        <p:spPr/>
+        <p:txBody>
+          <a:bodyPr/>
+          <a:lstStyle/>
+          <a:p>
+            <a:r>
+              <a:rPr lang="en-US" dirty="0"/>
+              <a:t>So this is the current workaround that most students, ourselves included use. It’s ok, but as you can see it actually sucks and needs improvement. The screen is cluttered from information duplication, seen *here* in the </a:t>
+            </a:r>
+            <a:r>
+              <a:rPr lang="en-US" dirty="0" err="1"/>
+              <a:t>topbar</a:t>
+            </a:r>
+            <a:r>
+              <a:rPr lang="en-US" dirty="0"/>
+              <a:t> and *here* in the sidebar. It’d be much better to just consolidate it all into one coherent screen which fits with our customizable view idea we’re trying to implement.</a:t>
+            </a:r>
+          </a:p>
+        </p:txBody>
+      </p:sp>
+      <p:sp>
+        <p:nvSpPr>
+          <p:cNvPr id="4" name="Slide Number Placeholder 3"/>
+          <p:cNvSpPr>
+            <a:spLocks noGrp="1"/>
+          </p:cNvSpPr>
+          <p:nvPr>
+            <p:ph type="sldNum" sz="quarter" idx="5"/>
+          </p:nvPr>
+        </p:nvSpPr>
+        <p:spPr/>
+        <p:txBody>
+          <a:bodyPr/>
+          <a:lstStyle/>
+          <a:p>
+            <a:fld id="{FC9F8D2F-DF87-4E8D-892D-1D9C898E4280}" type="slidenum">
+              <a:rPr lang="en-US" smtClean="0"/>
+              <a:t>3</a:t>
+            </a:fld>
+            <a:endParaRPr lang="en-US"/>
+          </a:p>
+        </p:txBody>
+      </p:sp>
+    </p:spTree>
+    <p:extLst>
+      <p:ext uri="{BB962C8B-B14F-4D97-AF65-F5344CB8AC3E}">
+        <p14:creationId xmlns:p14="http://schemas.microsoft.com/office/powerpoint/2010/main" val="719727988"/>
+      </p:ext>
+    </p:extLst>
+  </p:cSld>
+  <p:clrMapOvr>
+    <a:masterClrMapping/>
+  </p:clrMapOvr>
+</p:notes>
 </file>
 
 <file path=ppt/slideLayouts/slideLayout1.xml><?xml version="1.0" encoding="utf-8"?>
@@ -5131,7 +5642,7 @@
           </p:nvPr>
         </p:nvPicPr>
         <p:blipFill>
-          <a:blip r:embed="rId2"/>
+          <a:blip r:embed="rId3"/>
           <a:srcRect r="6221" b="-1"/>
           <a:stretch>
             <a:fillRect/>
@@ -6434,7 +6945,7 @@
           <p:cNvPr id="2" name="Title 1">
             <a:extLst>
               <a:ext uri="{FF2B5EF4-FFF2-40B4-BE49-F238E27FC236}">
-                <a16:creationId xmlns:a16="http://schemas.microsoft.com/office/drawing/2014/main" id="{21A33ED2-2FE0-2D84-4567-165D2858CBC6}"/>
+                <a16:creationId xmlns:a16="http://schemas.microsoft.com/office/drawing/2014/main" id="{CA267BC9-37FA-2B21-86EC-08DAB1484C41}"/>
               </a:ext>
             </a:extLst>
           </p:cNvPr>
@@ -6452,7 +6963,7 @@
           <a:p>
             <a:r>
               <a:rPr lang="en-US" dirty="0"/>
-              <a:t>AI advisor (hallucinations don’t exist what are you talking about)</a:t>
+              <a:t>Customizable layout</a:t>
             </a:r>
           </a:p>
         </p:txBody>
@@ -6462,7 +6973,7 @@
           <p:cNvPr id="3" name="Content Placeholder 2">
             <a:extLst>
               <a:ext uri="{FF2B5EF4-FFF2-40B4-BE49-F238E27FC236}">
-                <a16:creationId xmlns:a16="http://schemas.microsoft.com/office/drawing/2014/main" id="{CD8C4A33-ACE3-89C1-4AE6-ADFBA53AB21F}"/>
+                <a16:creationId xmlns:a16="http://schemas.microsoft.com/office/drawing/2014/main" id="{226F537D-BA02-8B44-4322-B0F0C31877C5}"/>
               </a:ext>
             </a:extLst>
           </p:cNvPr>
@@ -6478,14 +6989,29 @@
           <a:bodyPr/>
           <a:lstStyle/>
           <a:p>
-            <a:endParaRPr lang="en-US"/>
+            <a:r>
+              <a:rPr lang="en-US" dirty="0"/>
+              <a:t>Give the user more control over how courses are displayed and the information associated with them.</a:t>
+            </a:r>
+          </a:p>
+          <a:p>
+            <a:r>
+              <a:rPr lang="en-US" dirty="0"/>
+              <a:t>See next slide</a:t>
+            </a:r>
+          </a:p>
+          <a:p>
+            <a:r>
+              <a:rPr lang="en-US" dirty="0"/>
+              <a:t>(It would be really nice to have like a box that users can pull modules out of and place them where they want but that’s a stretch goal; at least I’d like buttons to hide the new information I told Daniel to add displays of)</a:t>
+            </a:r>
           </a:p>
         </p:txBody>
       </p:sp>
     </p:spTree>
     <p:extLst>
       <p:ext uri="{BB962C8B-B14F-4D97-AF65-F5344CB8AC3E}">
-        <p14:creationId xmlns:p14="http://schemas.microsoft.com/office/powerpoint/2010/main" val="2457606381"/>
+        <p14:creationId xmlns:p14="http://schemas.microsoft.com/office/powerpoint/2010/main" val="1918873932"/>
       </p:ext>
     </p:extLst>
   </p:cSld>
@@ -6517,7 +7043,7 @@
           <p:cNvPr id="2" name="Title 1">
             <a:extLst>
               <a:ext uri="{FF2B5EF4-FFF2-40B4-BE49-F238E27FC236}">
-                <a16:creationId xmlns:a16="http://schemas.microsoft.com/office/drawing/2014/main" id="{7ABAAAB3-E484-E8EB-7B3E-6E25F3A28252}"/>
+                <a16:creationId xmlns:a16="http://schemas.microsoft.com/office/drawing/2014/main" id="{9441E233-A118-C09D-2624-09955E55BF70}"/>
               </a:ext>
             </a:extLst>
           </p:cNvPr>
@@ -6535,7 +7061,7 @@
           <a:p>
             <a:r>
               <a:rPr lang="en-US" dirty="0"/>
-              <a:t>Customizable course planner software!</a:t>
+              <a:t>More course information, and how to manage it!</a:t>
             </a:r>
           </a:p>
         </p:txBody>
@@ -6545,7 +7071,7 @@
           <p:cNvPr id="3" name="Content Placeholder 2">
             <a:extLst>
               <a:ext uri="{FF2B5EF4-FFF2-40B4-BE49-F238E27FC236}">
-                <a16:creationId xmlns:a16="http://schemas.microsoft.com/office/drawing/2014/main" id="{167ABF96-518B-E31C-397C-3FE29B657D43}"/>
+                <a16:creationId xmlns:a16="http://schemas.microsoft.com/office/drawing/2014/main" id="{C15BACF4-3F67-3001-DB61-8035FD2781A7}"/>
               </a:ext>
             </a:extLst>
           </p:cNvPr>
@@ -6563,7 +7089,7 @@
           <a:p>
             <a:r>
               <a:rPr lang="en-US" dirty="0"/>
-              <a:t>May make students more likely to remain with/choose LU</a:t>
+              <a:t>You can now see more course information including difficulty, professor rating, and prerequisites. To avoid overload, the user is given the ability to toggle the visibility of each new section, as well as previously existing ones.</a:t>
             </a:r>
           </a:p>
         </p:txBody>
@@ -6571,7 +7097,7 @@
     </p:spTree>
     <p:extLst>
       <p:ext uri="{BB962C8B-B14F-4D97-AF65-F5344CB8AC3E}">
-        <p14:creationId xmlns:p14="http://schemas.microsoft.com/office/powerpoint/2010/main" val="3872863384"/>
+        <p14:creationId xmlns:p14="http://schemas.microsoft.com/office/powerpoint/2010/main" val="2026042837"/>
       </p:ext>
     </p:extLst>
   </p:cSld>
@@ -6603,7 +7129,7 @@
           <p:cNvPr id="2" name="Title 1">
             <a:extLst>
               <a:ext uri="{FF2B5EF4-FFF2-40B4-BE49-F238E27FC236}">
-                <a16:creationId xmlns:a16="http://schemas.microsoft.com/office/drawing/2014/main" id="{9441E233-A118-C09D-2624-09955E55BF70}"/>
+                <a16:creationId xmlns:a16="http://schemas.microsoft.com/office/drawing/2014/main" id="{7ABAAAB3-E484-E8EB-7B3E-6E25F3A28252}"/>
               </a:ext>
             </a:extLst>
           </p:cNvPr>
@@ -6621,7 +7147,7 @@
           <a:p>
             <a:r>
               <a:rPr lang="en-US" dirty="0"/>
-              <a:t>More course information, and how to manage it!</a:t>
+              <a:t>Customizable course planner software!</a:t>
             </a:r>
           </a:p>
         </p:txBody>
@@ -6631,7 +7157,7 @@
           <p:cNvPr id="3" name="Content Placeholder 2">
             <a:extLst>
               <a:ext uri="{FF2B5EF4-FFF2-40B4-BE49-F238E27FC236}">
-                <a16:creationId xmlns:a16="http://schemas.microsoft.com/office/drawing/2014/main" id="{C15BACF4-3F67-3001-DB61-8035FD2781A7}"/>
+                <a16:creationId xmlns:a16="http://schemas.microsoft.com/office/drawing/2014/main" id="{167ABF96-518B-E31C-397C-3FE29B657D43}"/>
               </a:ext>
             </a:extLst>
           </p:cNvPr>
@@ -6647,14 +7173,31 @@
           <a:bodyPr/>
           <a:lstStyle/>
           <a:p>
-            <a:endParaRPr lang="en-US"/>
+            <a:r>
+              <a:rPr lang="en-US" dirty="0"/>
+              <a:t>May make students more likely to remain with/choose LU</a:t>
+            </a:r>
+          </a:p>
+          <a:p>
+            <a:r>
+              <a:rPr lang="en-US" dirty="0"/>
+              <a:t>You can optimize your course plan for time, skill, most credits, include a backup plan, </a:t>
+            </a:r>
+            <a:r>
+              <a:rPr lang="en-US" dirty="0" err="1"/>
+              <a:t>ect</a:t>
+            </a:r>
+            <a:r>
+              <a:rPr lang="en-US" dirty="0"/>
+              <a:t>.</a:t>
+            </a:r>
           </a:p>
         </p:txBody>
       </p:sp>
     </p:spTree>
     <p:extLst>
       <p:ext uri="{BB962C8B-B14F-4D97-AF65-F5344CB8AC3E}">
-        <p14:creationId xmlns:p14="http://schemas.microsoft.com/office/powerpoint/2010/main" val="2026042837"/>
+        <p14:creationId xmlns:p14="http://schemas.microsoft.com/office/powerpoint/2010/main" val="3872863384"/>
       </p:ext>
     </p:extLst>
   </p:cSld>
@@ -6665,6 +7208,606 @@
 </file>
 
 <file path=ppt/slides/slide8.xml><?xml version="1.0" encoding="utf-8"?>
+<p:sld xmlns:a="http://schemas.openxmlformats.org/drawingml/2006/main" xmlns:r="http://schemas.openxmlformats.org/officeDocument/2006/relationships" xmlns:p="http://schemas.openxmlformats.org/presentationml/2006/main">
+  <p:cSld>
+    <p:bg>
+      <p:bgPr>
+        <a:solidFill>
+          <a:schemeClr val="bg1"/>
+        </a:solidFill>
+        <a:effectLst/>
+      </p:bgPr>
+    </p:bg>
+    <p:spTree>
+      <p:nvGrpSpPr>
+        <p:cNvPr id="1" name=""/>
+        <p:cNvGrpSpPr/>
+        <p:nvPr/>
+      </p:nvGrpSpPr>
+      <p:grpSpPr>
+        <a:xfrm>
+          <a:off x="0" y="0"/>
+          <a:ext cx="0" cy="0"/>
+          <a:chOff x="0" y="0"/>
+          <a:chExt cx="0" cy="0"/>
+        </a:xfrm>
+      </p:grpSpPr>
+      <p:sp useBgFill="1">
+        <p:nvSpPr>
+          <p:cNvPr id="9" name="Rectangle 8">
+            <a:extLst>
+              <a:ext uri="{FF2B5EF4-FFF2-40B4-BE49-F238E27FC236}">
+                <a16:creationId xmlns:a16="http://schemas.microsoft.com/office/drawing/2014/main" id="{F13C74B1-5B17-4795-BED0-7140497B445A}"/>
+              </a:ext>
+              <a:ext uri="{C183D7F6-B498-43B3-948B-1728B52AA6E4}">
+                <adec:decorative xmlns:adec="http://schemas.microsoft.com/office/drawing/2017/decorative" val="1"/>
+              </a:ext>
+            </a:extLst>
+          </p:cNvPr>
+          <p:cNvSpPr>
+            <a:spLocks noGrp="1" noRot="1" noChangeAspect="1" noMove="1" noResize="1" noEditPoints="1" noAdjustHandles="1" noChangeArrowheads="1" noChangeShapeType="1" noTextEdit="1"/>
+          </p:cNvSpPr>
+          <p:nvPr>
+            <p:extLst>
+              <p:ext uri="{386F3935-93C4-4BCD-93E2-E3B085C9AB24}">
+                <p16:designElem xmlns:p16="http://schemas.microsoft.com/office/powerpoint/2015/main" val="1"/>
+              </p:ext>
+            </p:extLst>
+          </p:nvPr>
+        </p:nvSpPr>
+        <p:spPr>
+          <a:xfrm>
+            <a:off x="0" y="0"/>
+            <a:ext cx="12188952" cy="6858000"/>
+          </a:xfrm>
+          <a:prstGeom prst="rect">
+            <a:avLst/>
+          </a:prstGeom>
+          <a:ln>
+            <a:noFill/>
+          </a:ln>
+        </p:spPr>
+        <p:style>
+          <a:lnRef idx="2">
+            <a:schemeClr val="accent1">
+              <a:shade val="50000"/>
+            </a:schemeClr>
+          </a:lnRef>
+          <a:fillRef idx="1">
+            <a:schemeClr val="accent1"/>
+          </a:fillRef>
+          <a:effectRef idx="0">
+            <a:schemeClr val="accent1"/>
+          </a:effectRef>
+          <a:fontRef idx="minor">
+            <a:schemeClr val="lt1"/>
+          </a:fontRef>
+        </p:style>
+        <p:txBody>
+          <a:bodyPr rtlCol="0" anchor="ctr"/>
+          <a:lstStyle/>
+          <a:p>
+            <a:pPr algn="ctr"/>
+            <a:endParaRPr lang="en-US"/>
+          </a:p>
+        </p:txBody>
+      </p:sp>
+      <p:sp>
+        <p:nvSpPr>
+          <p:cNvPr id="2" name="Title 1">
+            <a:extLst>
+              <a:ext uri="{FF2B5EF4-FFF2-40B4-BE49-F238E27FC236}">
+                <a16:creationId xmlns:a16="http://schemas.microsoft.com/office/drawing/2014/main" id="{21A33ED2-2FE0-2D84-4567-165D2858CBC6}"/>
+              </a:ext>
+            </a:extLst>
+          </p:cNvPr>
+          <p:cNvSpPr>
+            <a:spLocks noGrp="1"/>
+          </p:cNvSpPr>
+          <p:nvPr>
+            <p:ph type="title"/>
+          </p:nvPr>
+        </p:nvSpPr>
+        <p:spPr>
+          <a:xfrm>
+            <a:off x="640080" y="325369"/>
+            <a:ext cx="4368602" cy="1956841"/>
+          </a:xfrm>
+        </p:spPr>
+        <p:txBody>
+          <a:bodyPr anchor="b">
+            <a:normAutofit/>
+          </a:bodyPr>
+          <a:lstStyle/>
+          <a:p>
+            <a:r>
+              <a:rPr lang="en-US" sz="3000"/>
+              <a:t>AI advisor (hallucinations don’t exist what are you talking about)</a:t>
+            </a:r>
+          </a:p>
+        </p:txBody>
+      </p:sp>
+      <p:sp>
+        <p:nvSpPr>
+          <p:cNvPr id="11" name="sketchy line">
+            <a:extLst>
+              <a:ext uri="{FF2B5EF4-FFF2-40B4-BE49-F238E27FC236}">
+                <a16:creationId xmlns:a16="http://schemas.microsoft.com/office/drawing/2014/main" id="{D4974D33-8DC5-464E-8C6D-BE58F0669C17}"/>
+              </a:ext>
+              <a:ext uri="{C183D7F6-B498-43B3-948B-1728B52AA6E4}">
+                <adec:decorative xmlns:adec="http://schemas.microsoft.com/office/drawing/2017/decorative" val="1"/>
+              </a:ext>
+            </a:extLst>
+          </p:cNvPr>
+          <p:cNvSpPr>
+            <a:spLocks noGrp="1" noRot="1" noChangeAspect="1" noMove="1" noResize="1" noEditPoints="1" noAdjustHandles="1" noChangeArrowheads="1" noChangeShapeType="1" noTextEdit="1"/>
+          </p:cNvSpPr>
+          <p:nvPr>
+            <p:extLst>
+              <p:ext uri="{386F3935-93C4-4BCD-93E2-E3B085C9AB24}">
+                <p16:designElem xmlns:p16="http://schemas.microsoft.com/office/powerpoint/2015/main" val="1"/>
+              </p:ext>
+            </p:extLst>
+          </p:nvPr>
+        </p:nvSpPr>
+        <p:spPr>
+          <a:xfrm>
+            <a:off x="640080" y="2586994"/>
+            <a:ext cx="3474720" cy="18288"/>
+          </a:xfrm>
+          <a:custGeom>
+            <a:avLst/>
+            <a:gdLst>
+              <a:gd name="csX0" fmla="*/ 0 w 3474720"/>
+              <a:gd name="csY0" fmla="*/ 0 h 18288"/>
+              <a:gd name="csX1" fmla="*/ 694944 w 3474720"/>
+              <a:gd name="csY1" fmla="*/ 0 h 18288"/>
+              <a:gd name="csX2" fmla="*/ 1355141 w 3474720"/>
+              <a:gd name="csY2" fmla="*/ 0 h 18288"/>
+              <a:gd name="csX3" fmla="*/ 2015338 w 3474720"/>
+              <a:gd name="csY3" fmla="*/ 0 h 18288"/>
+              <a:gd name="csX4" fmla="*/ 2779776 w 3474720"/>
+              <a:gd name="csY4" fmla="*/ 0 h 18288"/>
+              <a:gd name="csX5" fmla="*/ 3474720 w 3474720"/>
+              <a:gd name="csY5" fmla="*/ 0 h 18288"/>
+              <a:gd name="csX6" fmla="*/ 3474720 w 3474720"/>
+              <a:gd name="csY6" fmla="*/ 18288 h 18288"/>
+              <a:gd name="csX7" fmla="*/ 2779776 w 3474720"/>
+              <a:gd name="csY7" fmla="*/ 18288 h 18288"/>
+              <a:gd name="csX8" fmla="*/ 2189074 w 3474720"/>
+              <a:gd name="csY8" fmla="*/ 18288 h 18288"/>
+              <a:gd name="csX9" fmla="*/ 1528877 w 3474720"/>
+              <a:gd name="csY9" fmla="*/ 18288 h 18288"/>
+              <a:gd name="csX10" fmla="*/ 868680 w 3474720"/>
+              <a:gd name="csY10" fmla="*/ 18288 h 18288"/>
+              <a:gd name="csX11" fmla="*/ 0 w 3474720"/>
+              <a:gd name="csY11" fmla="*/ 18288 h 18288"/>
+              <a:gd name="csX12" fmla="*/ 0 w 3474720"/>
+              <a:gd name="csY12" fmla="*/ 0 h 18288"/>
+            </a:gdLst>
+            <a:ahLst/>
+            <a:cxnLst>
+              <a:cxn ang="0">
+                <a:pos x="csX0" y="csY0"/>
+              </a:cxn>
+              <a:cxn ang="0">
+                <a:pos x="csX1" y="csY1"/>
+              </a:cxn>
+              <a:cxn ang="0">
+                <a:pos x="csX2" y="csY2"/>
+              </a:cxn>
+              <a:cxn ang="0">
+                <a:pos x="csX3" y="csY3"/>
+              </a:cxn>
+              <a:cxn ang="0">
+                <a:pos x="csX4" y="csY4"/>
+              </a:cxn>
+              <a:cxn ang="0">
+                <a:pos x="csX5" y="csY5"/>
+              </a:cxn>
+              <a:cxn ang="0">
+                <a:pos x="csX6" y="csY6"/>
+              </a:cxn>
+              <a:cxn ang="0">
+                <a:pos x="csX7" y="csY7"/>
+              </a:cxn>
+              <a:cxn ang="0">
+                <a:pos x="csX8" y="csY8"/>
+              </a:cxn>
+              <a:cxn ang="0">
+                <a:pos x="csX9" y="csY9"/>
+              </a:cxn>
+              <a:cxn ang="0">
+                <a:pos x="csX10" y="csY10"/>
+              </a:cxn>
+              <a:cxn ang="0">
+                <a:pos x="csX11" y="csY11"/>
+              </a:cxn>
+              <a:cxn ang="0">
+                <a:pos x="csX12" y="csY12"/>
+              </a:cxn>
+            </a:cxnLst>
+            <a:rect l="l" t="t" r="r" b="b"/>
+            <a:pathLst>
+              <a:path w="3474720" h="18288" fill="none" extrusionOk="0">
+                <a:moveTo>
+                  <a:pt x="0" y="0"/>
+                </a:moveTo>
+                <a:cubicBezTo>
+                  <a:pt x="224454" y="-14544"/>
+                  <a:pt x="495407" y="26540"/>
+                  <a:pt x="694944" y="0"/>
+                </a:cubicBezTo>
+                <a:cubicBezTo>
+                  <a:pt x="894481" y="-26540"/>
+                  <a:pt x="1130063" y="24713"/>
+                  <a:pt x="1355141" y="0"/>
+                </a:cubicBezTo>
+                <a:cubicBezTo>
+                  <a:pt x="1580219" y="-24713"/>
+                  <a:pt x="1820099" y="26695"/>
+                  <a:pt x="2015338" y="0"/>
+                </a:cubicBezTo>
+                <a:cubicBezTo>
+                  <a:pt x="2210577" y="-26695"/>
+                  <a:pt x="2402045" y="165"/>
+                  <a:pt x="2779776" y="0"/>
+                </a:cubicBezTo>
+                <a:cubicBezTo>
+                  <a:pt x="3157507" y="-165"/>
+                  <a:pt x="3286859" y="-15571"/>
+                  <a:pt x="3474720" y="0"/>
+                </a:cubicBezTo>
+                <a:cubicBezTo>
+                  <a:pt x="3474286" y="7551"/>
+                  <a:pt x="3474253" y="9822"/>
+                  <a:pt x="3474720" y="18288"/>
+                </a:cubicBezTo>
+                <a:cubicBezTo>
+                  <a:pt x="3233904" y="29845"/>
+                  <a:pt x="2945134" y="-5256"/>
+                  <a:pt x="2779776" y="18288"/>
+                </a:cubicBezTo>
+                <a:cubicBezTo>
+                  <a:pt x="2614418" y="41832"/>
+                  <a:pt x="2339768" y="22709"/>
+                  <a:pt x="2189074" y="18288"/>
+                </a:cubicBezTo>
+                <a:cubicBezTo>
+                  <a:pt x="2038380" y="13867"/>
+                  <a:pt x="1817434" y="-4947"/>
+                  <a:pt x="1528877" y="18288"/>
+                </a:cubicBezTo>
+                <a:cubicBezTo>
+                  <a:pt x="1240320" y="41523"/>
+                  <a:pt x="1042447" y="37198"/>
+                  <a:pt x="868680" y="18288"/>
+                </a:cubicBezTo>
+                <a:cubicBezTo>
+                  <a:pt x="694913" y="-622"/>
+                  <a:pt x="233232" y="44909"/>
+                  <a:pt x="0" y="18288"/>
+                </a:cubicBezTo>
+                <a:cubicBezTo>
+                  <a:pt x="60" y="11696"/>
+                  <a:pt x="66" y="3758"/>
+                  <a:pt x="0" y="0"/>
+                </a:cubicBezTo>
+                <a:close/>
+              </a:path>
+              <a:path w="3474720" h="18288" stroke="0" extrusionOk="0">
+                <a:moveTo>
+                  <a:pt x="0" y="0"/>
+                </a:moveTo>
+                <a:cubicBezTo>
+                  <a:pt x="202328" y="-14716"/>
+                  <a:pt x="332722" y="-11499"/>
+                  <a:pt x="625450" y="0"/>
+                </a:cubicBezTo>
+                <a:cubicBezTo>
+                  <a:pt x="918178" y="11499"/>
+                  <a:pt x="1096688" y="5123"/>
+                  <a:pt x="1389888" y="0"/>
+                </a:cubicBezTo>
+                <a:cubicBezTo>
+                  <a:pt x="1683088" y="-5123"/>
+                  <a:pt x="1835981" y="-14038"/>
+                  <a:pt x="1980590" y="0"/>
+                </a:cubicBezTo>
+                <a:cubicBezTo>
+                  <a:pt x="2125199" y="14038"/>
+                  <a:pt x="2396099" y="-7203"/>
+                  <a:pt x="2571293" y="0"/>
+                </a:cubicBezTo>
+                <a:cubicBezTo>
+                  <a:pt x="2746487" y="7203"/>
+                  <a:pt x="3041609" y="-12036"/>
+                  <a:pt x="3474720" y="0"/>
+                </a:cubicBezTo>
+                <a:cubicBezTo>
+                  <a:pt x="3474638" y="4406"/>
+                  <a:pt x="3474631" y="9982"/>
+                  <a:pt x="3474720" y="18288"/>
+                </a:cubicBezTo>
+                <a:cubicBezTo>
+                  <a:pt x="3324873" y="21876"/>
+                  <a:pt x="3136771" y="12587"/>
+                  <a:pt x="2814523" y="18288"/>
+                </a:cubicBezTo>
+                <a:cubicBezTo>
+                  <a:pt x="2492275" y="23989"/>
+                  <a:pt x="2294402" y="47111"/>
+                  <a:pt x="2154326" y="18288"/>
+                </a:cubicBezTo>
+                <a:cubicBezTo>
+                  <a:pt x="2014250" y="-10535"/>
+                  <a:pt x="1820317" y="33903"/>
+                  <a:pt x="1494130" y="18288"/>
+                </a:cubicBezTo>
+                <a:cubicBezTo>
+                  <a:pt x="1167943" y="2673"/>
+                  <a:pt x="948432" y="14868"/>
+                  <a:pt x="729691" y="18288"/>
+                </a:cubicBezTo>
+                <a:cubicBezTo>
+                  <a:pt x="510950" y="21708"/>
+                  <a:pt x="264032" y="24354"/>
+                  <a:pt x="0" y="18288"/>
+                </a:cubicBezTo>
+                <a:cubicBezTo>
+                  <a:pt x="189" y="14288"/>
+                  <a:pt x="-703" y="3747"/>
+                  <a:pt x="0" y="0"/>
+                </a:cubicBezTo>
+                <a:close/>
+              </a:path>
+            </a:pathLst>
+          </a:custGeom>
+          <a:solidFill>
+            <a:schemeClr val="accent2"/>
+          </a:solidFill>
+          <a:ln w="44450" cap="rnd">
+            <a:solidFill>
+              <a:schemeClr val="accent2"/>
+            </a:solidFill>
+            <a:round/>
+            <a:extLst>
+              <a:ext uri="{C807C97D-BFC1-408E-A445-0C87EB9F89A2}">
+                <ask:lineSketchStyleProps xmlns:ask="http://schemas.microsoft.com/office/drawing/2018/sketchyshapes" sd="2863741219">
+                  <a:prstGeom prst="rect">
+                    <a:avLst/>
+                  </a:prstGeom>
+                  <ask:type>
+                    <ask:lineSketchFreehand/>
+                  </ask:type>
+                </ask:lineSketchStyleProps>
+              </a:ext>
+            </a:extLst>
+          </a:ln>
+        </p:spPr>
+        <p:style>
+          <a:lnRef idx="2">
+            <a:schemeClr val="accent1">
+              <a:shade val="50000"/>
+            </a:schemeClr>
+          </a:lnRef>
+          <a:fillRef idx="1">
+            <a:schemeClr val="accent1"/>
+          </a:fillRef>
+          <a:effectRef idx="0">
+            <a:schemeClr val="accent1"/>
+          </a:effectRef>
+          <a:fontRef idx="minor">
+            <a:schemeClr val="lt1"/>
+          </a:fontRef>
+        </p:style>
+        <p:txBody>
+          <a:bodyPr rtlCol="0" anchor="ctr"/>
+          <a:lstStyle/>
+          <a:p>
+            <a:pPr algn="ctr"/>
+            <a:endParaRPr lang="en-US"/>
+          </a:p>
+        </p:txBody>
+      </p:sp>
+      <p:sp>
+        <p:nvSpPr>
+          <p:cNvPr id="3" name="Content Placeholder 2">
+            <a:extLst>
+              <a:ext uri="{FF2B5EF4-FFF2-40B4-BE49-F238E27FC236}">
+                <a16:creationId xmlns:a16="http://schemas.microsoft.com/office/drawing/2014/main" id="{CD8C4A33-ACE3-89C1-4AE6-ADFBA53AB21F}"/>
+              </a:ext>
+            </a:extLst>
+          </p:cNvPr>
+          <p:cNvSpPr>
+            <a:spLocks noGrp="1"/>
+          </p:cNvSpPr>
+          <p:nvPr>
+            <p:ph idx="1"/>
+          </p:nvPr>
+        </p:nvSpPr>
+        <p:spPr>
+          <a:xfrm>
+            <a:off x="640080" y="2872899"/>
+            <a:ext cx="4243589" cy="3320668"/>
+          </a:xfrm>
+        </p:spPr>
+        <p:txBody>
+          <a:bodyPr>
+            <a:normAutofit/>
+          </a:bodyPr>
+          <a:lstStyle/>
+          <a:p>
+            <a:r>
+              <a:rPr lang="en-US" sz="2200"/>
+              <a:t>This is a stretch goal and how we’ll shut down any criticism.</a:t>
+            </a:r>
+          </a:p>
+          <a:p>
+            <a:r>
+              <a:rPr lang="en-US" sz="2200"/>
+              <a:t>I feel like since there’s aprox 4 of us this would be a good work distribution and also this feature is like totally a good idea nothing bad could ever come of it</a:t>
+            </a:r>
+          </a:p>
+        </p:txBody>
+      </p:sp>
+      <p:pic>
+        <p:nvPicPr>
+          <p:cNvPr id="4" name="Picture 3" descr="Happy Skynet Day. 🤖 August 29, 1997. Skynet became self-aware. 29 years  later, we gave AI access to everything and asked it to make memes. So…  great job, everyone. 🫡">
+            <a:extLst>
+              <a:ext uri="{FF2B5EF4-FFF2-40B4-BE49-F238E27FC236}">
+                <a16:creationId xmlns:a16="http://schemas.microsoft.com/office/drawing/2014/main" id="{5D5879D5-B143-DC32-EC32-DE5C3738782F}"/>
+              </a:ext>
+            </a:extLst>
+          </p:cNvPr>
+          <p:cNvPicPr>
+            <a:picLocks noChangeAspect="1"/>
+          </p:cNvPicPr>
+          <p:nvPr/>
+        </p:nvPicPr>
+        <p:blipFill>
+          <a:blip r:embed="rId2"/>
+          <a:srcRect t="284" b="18"/>
+          <a:stretch>
+            <a:fillRect/>
+          </a:stretch>
+        </p:blipFill>
+        <p:spPr>
+          <a:xfrm>
+            <a:off x="5311702" y="10"/>
+            <a:ext cx="6878775" cy="6857990"/>
+          </a:xfrm>
+          <a:custGeom>
+            <a:avLst/>
+            <a:gdLst/>
+            <a:ahLst/>
+            <a:cxnLst/>
+            <a:rect l="l" t="t" r="r" b="b"/>
+            <a:pathLst>
+              <a:path w="6878775" h="6858000">
+                <a:moveTo>
+                  <a:pt x="1102973" y="0"/>
+                </a:moveTo>
+                <a:lnTo>
+                  <a:pt x="1160688" y="0"/>
+                </a:lnTo>
+                <a:lnTo>
+                  <a:pt x="983189" y="331786"/>
+                </a:lnTo>
+                <a:cubicBezTo>
+                  <a:pt x="914866" y="469145"/>
+                  <a:pt x="850355" y="608712"/>
+                  <a:pt x="789261" y="750263"/>
+                </a:cubicBezTo>
+                <a:cubicBezTo>
+                  <a:pt x="774307" y="784928"/>
+                  <a:pt x="759992" y="819849"/>
+                  <a:pt x="745295" y="854514"/>
+                </a:cubicBezTo>
+                <a:cubicBezTo>
+                  <a:pt x="756682" y="845393"/>
+                  <a:pt x="765489" y="833492"/>
+                  <a:pt x="770857" y="819975"/>
+                </a:cubicBezTo>
+                <a:cubicBezTo>
+                  <a:pt x="879943" y="589569"/>
+                  <a:pt x="999605" y="365513"/>
+                  <a:pt x="1131329" y="148742"/>
+                </a:cubicBezTo>
+                <a:lnTo>
+                  <a:pt x="1227589" y="0"/>
+                </a:lnTo>
+                <a:lnTo>
+                  <a:pt x="6878775" y="0"/>
+                </a:lnTo>
+                <a:lnTo>
+                  <a:pt x="6878775" y="6858000"/>
+                </a:lnTo>
+                <a:lnTo>
+                  <a:pt x="713521" y="6858000"/>
+                </a:lnTo>
+                <a:lnTo>
+                  <a:pt x="625642" y="6670527"/>
+                </a:lnTo>
+                <a:cubicBezTo>
+                  <a:pt x="507232" y="6398531"/>
+                  <a:pt x="403083" y="6118381"/>
+                  <a:pt x="312785" y="5830359"/>
+                </a:cubicBezTo>
+                <a:cubicBezTo>
+                  <a:pt x="278149" y="5719759"/>
+                  <a:pt x="248879" y="5607635"/>
+                  <a:pt x="212198" y="5480401"/>
+                </a:cubicBezTo>
+                <a:cubicBezTo>
+                  <a:pt x="212208" y="5491601"/>
+                  <a:pt x="212803" y="5502788"/>
+                  <a:pt x="213988" y="5513923"/>
+                </a:cubicBezTo>
+                <a:cubicBezTo>
+                  <a:pt x="264089" y="5723695"/>
+                  <a:pt x="307290" y="5935370"/>
+                  <a:pt x="365826" y="6142729"/>
+                </a:cubicBezTo>
+                <a:cubicBezTo>
+                  <a:pt x="433152" y="6380817"/>
+                  <a:pt x="510068" y="6614016"/>
+                  <a:pt x="597975" y="6841549"/>
+                </a:cubicBezTo>
+                <a:lnTo>
+                  <a:pt x="604824" y="6858000"/>
+                </a:lnTo>
+                <a:lnTo>
+                  <a:pt x="552056" y="6858000"/>
+                </a:lnTo>
+                <a:lnTo>
+                  <a:pt x="539576" y="6828295"/>
+                </a:lnTo>
+                <a:cubicBezTo>
+                  <a:pt x="380597" y="6414594"/>
+                  <a:pt x="260223" y="5988893"/>
+                  <a:pt x="171555" y="5552906"/>
+                </a:cubicBezTo>
+                <a:cubicBezTo>
+                  <a:pt x="91163" y="5157998"/>
+                  <a:pt x="43746" y="4758899"/>
+                  <a:pt x="12305" y="4357388"/>
+                </a:cubicBezTo>
+                <a:cubicBezTo>
+                  <a:pt x="-14281" y="4013908"/>
+                  <a:pt x="4507" y="3672965"/>
+                  <a:pt x="46684" y="3331516"/>
+                </a:cubicBezTo>
+                <a:cubicBezTo>
+                  <a:pt x="127203" y="2664286"/>
+                  <a:pt x="277819" y="2007265"/>
+                  <a:pt x="496065" y="1371196"/>
+                </a:cubicBezTo>
+                <a:cubicBezTo>
+                  <a:pt x="636273" y="966066"/>
+                  <a:pt x="800445" y="573253"/>
+                  <a:pt x="995723" y="196614"/>
+                </a:cubicBezTo>
+                <a:close/>
+              </a:path>
+            </a:pathLst>
+          </a:custGeom>
+        </p:spPr>
+      </p:pic>
+    </p:spTree>
+    <p:extLst>
+      <p:ext uri="{BB962C8B-B14F-4D97-AF65-F5344CB8AC3E}">
+        <p14:creationId xmlns:p14="http://schemas.microsoft.com/office/powerpoint/2010/main" val="2457606381"/>
+      </p:ext>
+    </p:extLst>
+  </p:cSld>
+  <p:clrMapOvr>
+    <a:masterClrMapping/>
+  </p:clrMapOvr>
+</p:sld>
+</file>
+
+<file path=ppt/slides/slide9.xml><?xml version="1.0" encoding="utf-8"?>
 <p:sld xmlns:a="http://schemas.openxmlformats.org/drawingml/2006/main" xmlns:r="http://schemas.openxmlformats.org/officeDocument/2006/relationships" xmlns:p="http://schemas.openxmlformats.org/presentationml/2006/main">
   <p:cSld>
     <p:bg>
@@ -7586,13 +8729,8 @@
           <a:p>
             <a:r>
               <a:rPr lang="en-US" dirty="0"/>
-              <a:t>Link goes here [have a live server that they can play around with but that we also then </a:t>
-            </a:r>
-            <a:r>
-              <a:rPr lang="en-US"/>
-              <a:t>tab over to]</a:t>
-            </a:r>
-            <a:endParaRPr lang="en-US" dirty="0"/>
+              <a:t>Link goes here [have a live server that they can play around with but that we also then tab over to]</a:t>
+            </a:r>
           </a:p>
         </p:txBody>
       </p:sp>
@@ -7922,4 +9060,319 @@
     </a:ext>
   </a:extLst>
 </a:theme>
+</file>
+
+<file path=ppt/theme/theme2.xml><?xml version="1.0" encoding="utf-8"?>
+<a:theme xmlns:a="http://schemas.openxmlformats.org/drawingml/2006/main" name="Office Theme">
+  <a:themeElements>
+    <a:clrScheme name="Office">
+      <a:dk1>
+        <a:sysClr val="windowText" lastClr="000000"/>
+      </a:dk1>
+      <a:lt1>
+        <a:sysClr val="window" lastClr="FFFFFF"/>
+      </a:lt1>
+      <a:dk2>
+        <a:srgbClr val="0E2841"/>
+      </a:dk2>
+      <a:lt2>
+        <a:srgbClr val="E8E8E8"/>
+      </a:lt2>
+      <a:accent1>
+        <a:srgbClr val="156082"/>
+      </a:accent1>
+      <a:accent2>
+        <a:srgbClr val="E97132"/>
+      </a:accent2>
+      <a:accent3>
+        <a:srgbClr val="196B24"/>
+      </a:accent3>
+      <a:accent4>
+        <a:srgbClr val="0F9ED5"/>
+      </a:accent4>
+      <a:accent5>
+        <a:srgbClr val="A02B93"/>
+      </a:accent5>
+      <a:accent6>
+        <a:srgbClr val="4EA72E"/>
+      </a:accent6>
+      <a:hlink>
+        <a:srgbClr val="467886"/>
+      </a:hlink>
+      <a:folHlink>
+        <a:srgbClr val="96607D"/>
+      </a:folHlink>
+    </a:clrScheme>
+    <a:fontScheme name="Office">
+      <a:majorFont>
+        <a:latin typeface="Aptos Display" panose="02110004020202020204"/>
+        <a:ea typeface=""/>
+        <a:cs typeface=""/>
+        <a:font script="Jpan" typeface="游ゴシック Light"/>
+        <a:font script="Hang" typeface="맑은 고딕"/>
+        <a:font script="Hans" typeface="等线 Light"/>
+        <a:font script="Hant" typeface="新細明體"/>
+        <a:font script="Arab" typeface="Times New Roman"/>
+        <a:font script="Hebr" typeface="Times New Roman"/>
+        <a:font script="Thai" typeface="Angsana New"/>
+        <a:font script="Ethi" typeface="Nyala"/>
+        <a:font script="Beng" typeface="Vrinda"/>
+        <a:font script="Gujr" typeface="Shruti"/>
+        <a:font script="Khmr" typeface="MoolBoran"/>
+        <a:font script="Knda" typeface="Tunga"/>
+        <a:font script="Guru" typeface="Raavi"/>
+        <a:font script="Cans" typeface="Euphemia"/>
+        <a:font script="Cher" typeface="Plantagenet Cherokee"/>
+        <a:font script="Yiii" typeface="Microsoft Yi Baiti"/>
+        <a:font script="Tibt" typeface="Microsoft Himalaya"/>
+        <a:font script="Thaa" typeface="MV Boli"/>
+        <a:font script="Deva" typeface="Mangal"/>
+        <a:font script="Telu" typeface="Gautami"/>
+        <a:font script="Taml" typeface="Latha"/>
+        <a:font script="Syrc" typeface="Estrangelo Edessa"/>
+        <a:font script="Orya" typeface="Kalinga"/>
+        <a:font script="Mlym" typeface="Kartika"/>
+        <a:font script="Laoo" typeface="DokChampa"/>
+        <a:font script="Sinh" typeface="Iskoola Pota"/>
+        <a:font script="Mong" typeface="Mongolian Baiti"/>
+        <a:font script="Viet" typeface="Times New Roman"/>
+        <a:font script="Uigh" typeface="Microsoft Uighur"/>
+        <a:font script="Geor" typeface="Sylfaen"/>
+        <a:font script="Armn" typeface="Arial"/>
+        <a:font script="Bugi" typeface="Leelawadee UI"/>
+        <a:font script="Bopo" typeface="Microsoft JhengHei"/>
+        <a:font script="Java" typeface="Javanese Text"/>
+        <a:font script="Lisu" typeface="Segoe UI"/>
+        <a:font script="Mymr" typeface="Myanmar Text"/>
+        <a:font script="Nkoo" typeface="Ebrima"/>
+        <a:font script="Olck" typeface="Nirmala UI"/>
+        <a:font script="Osma" typeface="Ebrima"/>
+        <a:font script="Phag" typeface="Phagspa"/>
+        <a:font script="Syrn" typeface="Estrangelo Edessa"/>
+        <a:font script="Syrj" typeface="Estrangelo Edessa"/>
+        <a:font script="Syre" typeface="Estrangelo Edessa"/>
+        <a:font script="Sora" typeface="Nirmala UI"/>
+        <a:font script="Tale" typeface="Microsoft Tai Le"/>
+        <a:font script="Talu" typeface="Microsoft New Tai Lue"/>
+        <a:font script="Tfng" typeface="Ebrima"/>
+      </a:majorFont>
+      <a:minorFont>
+        <a:latin typeface="Aptos" panose="02110004020202020204"/>
+        <a:ea typeface=""/>
+        <a:cs typeface=""/>
+        <a:font script="Jpan" typeface="游ゴシック"/>
+        <a:font script="Hang" typeface="맑은 고딕"/>
+        <a:font script="Hans" typeface="等线"/>
+        <a:font script="Hant" typeface="新細明體"/>
+        <a:font script="Arab" typeface="Arial"/>
+        <a:font script="Hebr" typeface="Arial"/>
+        <a:font script="Thai" typeface="Cordia New"/>
+        <a:font script="Ethi" typeface="Nyala"/>
+        <a:font script="Beng" typeface="Vrinda"/>
+        <a:font script="Gujr" typeface="Shruti"/>
+        <a:font script="Khmr" typeface="DaunPenh"/>
+        <a:font script="Knda" typeface="Tunga"/>
+        <a:font script="Guru" typeface="Raavi"/>
+        <a:font script="Cans" typeface="Euphemia"/>
+        <a:font script="Cher" typeface="Plantagenet Cherokee"/>
+        <a:font script="Yiii" typeface="Microsoft Yi Baiti"/>
+        <a:font script="Tibt" typeface="Microsoft Himalaya"/>
+        <a:font script="Thaa" typeface="MV Boli"/>
+        <a:font script="Deva" typeface="Mangal"/>
+        <a:font script="Telu" typeface="Gautami"/>
+        <a:font script="Taml" typeface="Latha"/>
+        <a:font script="Syrc" typeface="Estrangelo Edessa"/>
+        <a:font script="Orya" typeface="Kalinga"/>
+        <a:font script="Mlym" typeface="Kartika"/>
+        <a:font script="Laoo" typeface="DokChampa"/>
+        <a:font script="Sinh" typeface="Iskoola Pota"/>
+        <a:font script="Mong" typeface="Mongolian Baiti"/>
+        <a:font script="Viet" typeface="Arial"/>
+        <a:font script="Uigh" typeface="Microsoft Uighur"/>
+        <a:font script="Geor" typeface="Sylfaen"/>
+        <a:font script="Armn" typeface="Arial"/>
+        <a:font script="Bugi" typeface="Leelawadee UI"/>
+        <a:font script="Bopo" typeface="Microsoft JhengHei"/>
+        <a:font script="Java" typeface="Javanese Text"/>
+        <a:font script="Lisu" typeface="Segoe UI"/>
+        <a:font script="Mymr" typeface="Myanmar Text"/>
+        <a:font script="Nkoo" typeface="Ebrima"/>
+        <a:font script="Olck" typeface="Nirmala UI"/>
+        <a:font script="Osma" typeface="Ebrima"/>
+        <a:font script="Phag" typeface="Phagspa"/>
+        <a:font script="Syrn" typeface="Estrangelo Edessa"/>
+        <a:font script="Syrj" typeface="Estrangelo Edessa"/>
+        <a:font script="Syre" typeface="Estrangelo Edessa"/>
+        <a:font script="Sora" typeface="Nirmala UI"/>
+        <a:font script="Tale" typeface="Microsoft Tai Le"/>
+        <a:font script="Talu" typeface="Microsoft New Tai Lue"/>
+        <a:font script="Tfng" typeface="Ebrima"/>
+      </a:minorFont>
+    </a:fontScheme>
+    <a:fmtScheme name="Office">
+      <a:fillStyleLst>
+        <a:solidFill>
+          <a:schemeClr val="phClr"/>
+        </a:solidFill>
+        <a:gradFill rotWithShape="1">
+          <a:gsLst>
+            <a:gs pos="0">
+              <a:schemeClr val="phClr">
+                <a:lumMod val="110000"/>
+                <a:satMod val="105000"/>
+                <a:tint val="67000"/>
+              </a:schemeClr>
+            </a:gs>
+            <a:gs pos="50000">
+              <a:schemeClr val="phClr">
+                <a:lumMod val="105000"/>
+                <a:satMod val="103000"/>
+                <a:tint val="73000"/>
+              </a:schemeClr>
+            </a:gs>
+            <a:gs pos="100000">
+              <a:schemeClr val="phClr">
+                <a:lumMod val="105000"/>
+                <a:satMod val="109000"/>
+                <a:tint val="81000"/>
+              </a:schemeClr>
+            </a:gs>
+          </a:gsLst>
+          <a:lin ang="5400000" scaled="0"/>
+        </a:gradFill>
+        <a:gradFill rotWithShape="1">
+          <a:gsLst>
+            <a:gs pos="0">
+              <a:schemeClr val="phClr">
+                <a:satMod val="103000"/>
+                <a:lumMod val="102000"/>
+                <a:tint val="94000"/>
+              </a:schemeClr>
+            </a:gs>
+            <a:gs pos="50000">
+              <a:schemeClr val="phClr">
+                <a:satMod val="110000"/>
+                <a:lumMod val="100000"/>
+                <a:shade val="100000"/>
+              </a:schemeClr>
+            </a:gs>
+            <a:gs pos="100000">
+              <a:schemeClr val="phClr">
+                <a:lumMod val="99000"/>
+                <a:satMod val="120000"/>
+                <a:shade val="78000"/>
+              </a:schemeClr>
+            </a:gs>
+          </a:gsLst>
+          <a:lin ang="5400000" scaled="0"/>
+        </a:gradFill>
+      </a:fillStyleLst>
+      <a:lnStyleLst>
+        <a:ln w="12700" cap="flat" cmpd="sng" algn="ctr">
+          <a:solidFill>
+            <a:schemeClr val="phClr"/>
+          </a:solidFill>
+          <a:prstDash val="solid"/>
+          <a:miter lim="800000"/>
+        </a:ln>
+        <a:ln w="19050" cap="flat" cmpd="sng" algn="ctr">
+          <a:solidFill>
+            <a:schemeClr val="phClr"/>
+          </a:solidFill>
+          <a:prstDash val="solid"/>
+          <a:miter lim="800000"/>
+        </a:ln>
+        <a:ln w="25400" cap="flat" cmpd="sng" algn="ctr">
+          <a:solidFill>
+            <a:schemeClr val="phClr"/>
+          </a:solidFill>
+          <a:prstDash val="solid"/>
+          <a:miter lim="800000"/>
+        </a:ln>
+      </a:lnStyleLst>
+      <a:effectStyleLst>
+        <a:effectStyle>
+          <a:effectLst/>
+        </a:effectStyle>
+        <a:effectStyle>
+          <a:effectLst/>
+        </a:effectStyle>
+        <a:effectStyle>
+          <a:effectLst>
+            <a:outerShdw blurRad="57150" dist="19050" dir="5400000" algn="ctr" rotWithShape="0">
+              <a:srgbClr val="000000">
+                <a:alpha val="63000"/>
+              </a:srgbClr>
+            </a:outerShdw>
+          </a:effectLst>
+        </a:effectStyle>
+      </a:effectStyleLst>
+      <a:bgFillStyleLst>
+        <a:solidFill>
+          <a:schemeClr val="phClr"/>
+        </a:solidFill>
+        <a:solidFill>
+          <a:schemeClr val="phClr">
+            <a:tint val="95000"/>
+            <a:satMod val="170000"/>
+          </a:schemeClr>
+        </a:solidFill>
+        <a:gradFill rotWithShape="1">
+          <a:gsLst>
+            <a:gs pos="0">
+              <a:schemeClr val="phClr">
+                <a:tint val="93000"/>
+                <a:satMod val="150000"/>
+                <a:shade val="98000"/>
+                <a:lumMod val="102000"/>
+              </a:schemeClr>
+            </a:gs>
+            <a:gs pos="50000">
+              <a:schemeClr val="phClr">
+                <a:tint val="98000"/>
+                <a:satMod val="130000"/>
+                <a:shade val="90000"/>
+                <a:lumMod val="103000"/>
+              </a:schemeClr>
+            </a:gs>
+            <a:gs pos="100000">
+              <a:schemeClr val="phClr">
+                <a:shade val="63000"/>
+                <a:satMod val="120000"/>
+              </a:schemeClr>
+            </a:gs>
+          </a:gsLst>
+          <a:lin ang="5400000" scaled="0"/>
+        </a:gradFill>
+      </a:bgFillStyleLst>
+    </a:fmtScheme>
+  </a:themeElements>
+  <a:objectDefaults>
+    <a:lnDef>
+      <a:spPr/>
+      <a:bodyPr/>
+      <a:lstStyle/>
+      <a:style>
+        <a:lnRef idx="2">
+          <a:schemeClr val="accent1"/>
+        </a:lnRef>
+        <a:fillRef idx="0">
+          <a:schemeClr val="accent1"/>
+        </a:fillRef>
+        <a:effectRef idx="1">
+          <a:schemeClr val="accent1"/>
+        </a:effectRef>
+        <a:fontRef idx="minor">
+          <a:schemeClr val="tx1"/>
+        </a:fontRef>
+      </a:style>
+    </a:lnDef>
+  </a:objectDefaults>
+  <a:extraClrSchemeLst/>
+  <a:extLst>
+    <a:ext uri="{05A4C25C-085E-4340-85A3-A5531E510DB2}">
+      <thm15:themeFamily xmlns:thm15="http://schemas.microsoft.com/office/thememl/2012/main" name="Office Theme" id="{2E142A2C-CD16-42D6-873A-C26D2A0506FA}" vid="{1BDDFF52-6CD6-40A5-AB3C-68EB2F1E4D0A}"/>
+    </a:ext>
+  </a:extLst>
+</a:theme>
 </file>
</xml_diff>